<commit_message>
Add the session feedback QR to the closing slide
render_title takes an optional qr/qr_label pair and draws the code on a
white pad in the right margin, so it stays scannable against the dark
band. The Questions slide uses it for the OpenSearchCon feedback code.

Co-Authored-By: Claude Opus 5 (1M context) <noreply@anthropic.com>
</commit_message>
<xml_diff>
--- a/ldp_for_search_slides.pptx
+++ b/ldp_for_search_slides.pptx
@@ -10635,7 +10635,110 @@
       </p:sp>
       <p:sp>
         <p:nvSpPr>
-          <p:cNvPr id="4" name="TextBox 3"/>
+          <p:cNvPr id="4" name="Rectangle 3"/>
+          <p:cNvSpPr/>
+          <p:nvPr/>
+        </p:nvSpPr>
+        <p:spPr>
+          <a:xfrm>
+            <a:off x="8771839" y="1975104"/>
+            <a:ext cx="2724912" cy="2724912"/>
+          </a:xfrm>
+          <a:prstGeom prst="rect">
+            <a:avLst/>
+          </a:prstGeom>
+          <a:solidFill>
+            <a:srgbClr val="FFFFFF"/>
+          </a:solidFill>
+          <a:ln>
+            <a:noFill/>
+          </a:ln>
+          <a:effectLst/>
+        </p:spPr>
+        <p:style>
+          <a:lnRef idx="1">
+            <a:schemeClr val="accent1"/>
+          </a:lnRef>
+          <a:fillRef idx="3">
+            <a:schemeClr val="accent1"/>
+          </a:fillRef>
+          <a:effectRef idx="2">
+            <a:schemeClr val="accent1"/>
+          </a:effectRef>
+          <a:fontRef idx="minor">
+            <a:schemeClr val="lt1"/>
+          </a:fontRef>
+        </p:style>
+        <p:txBody>
+          <a:bodyPr rtlCol="0" anchor="ctr"/>
+          <a:lstStyle/>
+          <a:p>
+            <a:pPr algn="ctr"/>
+          </a:p>
+        </p:txBody>
+      </p:sp>
+      <p:pic>
+        <p:nvPicPr>
+          <p:cNvPr id="5" name="Picture 4" descr="leveraging-ldp-for-high-trust-opensearch-ubi_zemerick_1212636_feedback-code.png"/>
+          <p:cNvPicPr>
+            <a:picLocks noChangeAspect="1"/>
+          </p:cNvPicPr>
+          <p:nvPr/>
+        </p:nvPicPr>
+        <p:blipFill>
+          <a:blip r:embed="rId2"/>
+          <a:stretch>
+            <a:fillRect/>
+          </a:stretch>
+        </p:blipFill>
+        <p:spPr>
+          <a:xfrm>
+            <a:off x="8899855" y="2103120"/>
+            <a:ext cx="2468880" cy="2468880"/>
+          </a:xfrm>
+          <a:prstGeom prst="rect">
+            <a:avLst/>
+          </a:prstGeom>
+        </p:spPr>
+      </p:pic>
+      <p:sp>
+        <p:nvSpPr>
+          <p:cNvPr id="6" name="TextBox 5"/>
+          <p:cNvSpPr txBox="1"/>
+          <p:nvPr/>
+        </p:nvSpPr>
+        <p:spPr>
+          <a:xfrm>
+            <a:off x="8771839" y="4809744"/>
+            <a:ext cx="2724912" cy="365760"/>
+          </a:xfrm>
+          <a:prstGeom prst="rect">
+            <a:avLst/>
+          </a:prstGeom>
+          <a:noFill/>
+        </p:spPr>
+        <p:txBody>
+          <a:bodyPr wrap="square">
+            <a:spAutoFit/>
+          </a:bodyPr>
+          <a:lstStyle/>
+          <a:p>
+            <a:pPr algn="ctr"/>
+            <a:r>
+              <a:rPr sz="1400" b="0">
+                <a:solidFill>
+                  <a:srgbClr val="8EB8E8"/>
+                </a:solidFill>
+                <a:latin typeface="Helvetica Neue"/>
+              </a:rPr>
+              <a:t>Session feedback</a:t>
+            </a:r>
+          </a:p>
+        </p:txBody>
+      </p:sp>
+      <p:sp>
+        <p:nvSpPr>
+          <p:cNvPr id="7" name="TextBox 6"/>
           <p:cNvSpPr txBox="1"/>
           <p:nvPr/>
         </p:nvSpPr>

</xml_diff>

<commit_message>
Point the demo slides at a notebook path that runs
Slide 21 asked for section 11 on its own, but section 11 needs the
cached WANDS data that section 10a loads, and no slide called for
running section 10 live. Following the slides as written raised a
NameError on the first cell of the Part 5 demo.

Slide 21 now names section 10a alongside 11, and slide 10 asks for it
while the notebook is already open, so Part 5 starts without a pause.
Verified end to end offline: sections 1 to 6, 9, 10a, 11.

Co-Authored-By: Claude Opus 5 (1M context) <noreply@anthropic.com>
</commit_message>
<xml_diff>
--- a/ldp_for_search_slides.pptx
+++ b/ldp_for_search_slides.pptx
@@ -602,7 +602,7 @@
           <a:lstStyle/>
           <a:p>
             <a:r>
-              <a:t>Read the 20 documents aloud. They fit in one breath. Then run section 9 and let the raw result speak. Do not rush this, it is the hinge of the talk.</a:t>
+              <a:t>Read the 20 documents aloud. They fit in one breath. Then run section 9 and let the raw result speak. Do not rush this, it is the hinge of the talk. Before you leave the notebook, run section 10a as well. It only loads the cached dataset, and having it already in the kernel is what keeps the Part 5 demo instant.</a:t>
             </a:r>
           </a:p>
         </p:txBody>
@@ -1442,7 +1442,7 @@
           <a:lstStyle/>
           <a:p>
             <a:r>
-              <a:t>Stress that no one in a segment sends a readable query, and the server does the aggregation on noised vectors only. There is no trusted intermediate step. Read the result off the notebook rather than a slide, because both halves matter. Individual recovery per segment runs 0.020, 0.020, 0.063, 0.070 and 0.030 against chance of 0.014 to 0.031, so roughly one to two and a half times chance, which is not usable. Segment identification is 5 of 5, exact. Same data, same epsilon of 1.0, two different questions.</a:t>
+              <a:t>Section 10a only loads the cached WANDS data, and section 11 raises a NameError without it, so run it first if you did not already run it back in Part 2. Stress that no one in a segment sends a readable query, and the server does the aggregation on noised vectors only. There is no trusted intermediate step. Read the result off the notebook rather than a slide, because both halves matter. Individual recovery per segment runs 0.020, 0.020, 0.063, 0.070 and 0.030 against chance of 0.014 to 0.031, so roughly one to two and a half times chance, which is not usable. Segment identification is 5 of 5, exact. Same data, same epsilon of 1.0, two different questions.</a:t>
             </a:r>
           </a:p>
         </p:txBody>
@@ -8317,7 +8317,7 @@
                 </a:solidFill>
                 <a:latin typeface="Helvetica Neue"/>
               </a:rPr>
-              <a:t>Notebook section 11</a:t>
+              <a:t>Notebook sections 10a and 11</a:t>
             </a:r>
           </a:p>
           <a:p>

</xml_diff>

<commit_message>
Thin the opening slides
Slide 2 drops the Philterd line and slide 4 drops two bullets, leaving
three: relevance is measured, what gets captured, and what happens
without it.

Two speaker notes still lean on the redaction credential that is no
longer a bullet, and slide 7 still links to philterd.ai, so both stay
available as spoken material. Learning-to-rank now appears on one slide
only, near the end, though the abstract promises it.

Co-Authored-By: Claude Opus 5 (1M context) <noreply@anthropic.com>
</commit_message>
<xml_diff>
--- a/ldp_for_search_slides.pptx
+++ b/ldp_for_search_slides.pptx
@@ -8585,31 +8585,6 @@
                 </a:solidFill>
                 <a:latin typeface="Helvetica Neue"/>
               </a:rPr>
-              <a:t>PII redaction tooling at Philterd</a:t>
-            </a:r>
-          </a:p>
-          <a:p>
-            <a:pPr marL="342900" indent="-342900">
-              <a:spcAft>
-                <a:spcPts val="2000"/>
-              </a:spcAft>
-            </a:pPr>
-            <a:r>
-              <a:rPr sz="2400" b="1">
-                <a:solidFill>
-                  <a:srgbClr val="005EB8"/>
-                </a:solidFill>
-                <a:latin typeface="Helvetica Neue"/>
-              </a:rPr>
-              <a:t>-   </a:t>
-            </a:r>
-            <a:r>
-              <a:rPr sz="2400" b="0" i="0">
-                <a:solidFill>
-                  <a:srgbClr val="141B2D"/>
-                </a:solidFill>
-                <a:latin typeface="Helvetica Neue"/>
-              </a:rPr>
               <a:t>Works in search, NLP, and privacy</a:t>
             </a:r>
           </a:p>
@@ -11528,32 +11503,7 @@
                 </a:solidFill>
                 <a:latin typeface="Helvetica Neue"/>
               </a:rPr>
-              <a:t>Which queries fire, which results get clicked, at which position</a:t>
-            </a:r>
-          </a:p>
-          <a:p>
-            <a:pPr marL="342900" indent="-342900">
-              <a:spcAft>
-                <a:spcPts val="1400"/>
-              </a:spcAft>
-            </a:pPr>
-            <a:r>
-              <a:rPr sz="2100" b="1">
-                <a:solidFill>
-                  <a:srgbClr val="005EB8"/>
-                </a:solidFill>
-                <a:latin typeface="Helvetica Neue"/>
-              </a:rPr>
-              <a:t>-   </a:t>
-            </a:r>
-            <a:r>
-              <a:rPr sz="2100" b="0" i="0">
-                <a:solidFill>
-                  <a:srgbClr val="141B2D"/>
-                </a:solidFill>
-                <a:latin typeface="Helvetica Neue"/>
-              </a:rPr>
-              <a:t>Learning-to-rank trains on exactly this signal</a:t>
+              <a:t>What queries, what's clicked, and where</a:t>
             </a:r>
           </a:p>
           <a:p>

</xml_diff>

<commit_message>
Reintroduce learning-to-rank in Part 1
The abstract promises LTR, but after the last trim it appeared only on
slide 27, near the end and unannounced. Slide 4 now closes on it: you
cannot train learning-to-rank on guesses. Set up early, discharged late.

Co-Authored-By: Claude Opus 5 (1M context) <noreply@anthropic.com>
</commit_message>
<xml_diff>
--- a/ldp_for_search_slides.pptx
+++ b/ldp_for_search_slides.pptx
@@ -11529,6 +11529,31 @@
                 <a:latin typeface="Helvetica Neue"/>
               </a:rPr>
               <a:t>Without measurement you are guessing</a:t>
+            </a:r>
+          </a:p>
+          <a:p>
+            <a:pPr marL="342900" indent="-342900">
+              <a:spcAft>
+                <a:spcPts val="1400"/>
+              </a:spcAft>
+            </a:pPr>
+            <a:r>
+              <a:rPr sz="2100" b="1">
+                <a:solidFill>
+                  <a:srgbClr val="005EB8"/>
+                </a:solidFill>
+                <a:latin typeface="Helvetica Neue"/>
+              </a:rPr>
+              <a:t>-   </a:t>
+            </a:r>
+            <a:r>
+              <a:rPr sz="2100" b="0" i="0">
+                <a:solidFill>
+                  <a:srgbClr val="141B2D"/>
+                </a:solidFill>
+                <a:latin typeface="Helvetica Neue"/>
+              </a:rPr>
+              <a:t>Learning-to-rank can't be trained on guesses</a:t>
             </a:r>
           </a:p>
         </p:txBody>

</xml_diff>

<commit_message>
Bring the speaker notes back in line with the deck
Eight notes had drifted as slides moved, and two of them were wrong
rather than imprecise.

The Part 3 divider still said seven minutes of mechanism and two
verification beats, when that part now runs slides 12 to 23 and carries
the evidence, the cost and the whole payoff. It now says so, and warns
that nothing marks the payoff any more.

The epsilon sweep note pointed forward to the real index curve as the
next slide, but that curve now comes before it, and it pointed at slide
16 for the attacker when the attacker is slide 17.

Four were stale pointers left by insertions and deletions, and two
described content that has since left the deck, the redaction credential
on the about slide and the word Laplace, which now appears nowhere.

Every slide N, next slide, previous slide and next part reference was
resolved against the current deck.

Co-Authored-By: Claude Opus 5 (1M context) <noreply@anthropic.com>
</commit_message>
<xml_diff>
--- a/ldp_for_search_slides.pptx
+++ b/ldp_for_search_slides.pptx
@@ -742,7 +742,7 @@
           <a:lstStyle/>
           <a:p>
             <a:r>
-              <a:t>About 7 minutes. Mechanism briefly, then two verification beats, weakest to strongest.</a:t>
+              <a:t>The longest part by far, about 25 minutes, because it carries the mechanism, the evidence, the cost and the payoff. Three evidence slides in order of strength, the distribution audit, then the epsilon comparison, then the attacker. Then what the noise costs, then what survives it. No divider marks the payoff any more, so the turn from the epsilon sweep to the asymmetry slide is yours to make out loud.</a:t>
             </a:r>
           </a:p>
         </p:txBody>
@@ -882,7 +882,7 @@
           <a:lstStyle/>
           <a:p>
             <a:r>
-              <a:t>One slide only. Resist the urge to teach differential privacy properly, there is not time and it is not the point of the talk. The noise is Laplace, but the word can wait for the next slide, where the shape is on screen and does the explaining for you. If someone asks here, one sentence: symmetric noise, equally likely to push the value up or down, centered on the truth. The formula is deliberately off the slide. If someone asks, the noise scale is sensitivity over epsilon, and sensitivity here is 1.0 per coordinate on vectors whose whole norm is 1, which is conservative rather than tight. The notes file has the longer answer. Do not volunteer the word, it is the only term in the deck with no definition behind it.</a:t>
+              <a:t>One slide only. Resist the urge to teach differential privacy properly, there is not time and it is not the point of the talk. The noise is Laplace, but the word appears on no slide, so leave it out unless asked. The shape on the next slide explains it. If someone asks here, one sentence: symmetric noise, equally likely to push the value up or down, centered on the truth. The formula is deliberately off the slide. If someone asks, the noise scale is sensitivity over epsilon, and sensitivity here is 1.0 per coordinate on vectors whose whole norm is 1, which is conservative rather than tight. The notes file has the longer answer. Do not volunteer the word, it is the only term in the deck with no definition behind it.</a:t>
             </a:r>
           </a:p>
         </p:txBody>
@@ -952,7 +952,7 @@
           <a:lstStyle/>
           <a:p>
             <a:r>
-              <a:t>This is the distributional check. It proves the mechanism is implemented correctly. It does not prove an attacker fails, which is why the next slide exists. Say what the thousand is, because the title does not: one query, one coordinate of its vector, and a thousand independent noise draws on that same true value. You cannot audit a random mechanism from one sample, so you repeat it until the shape shows. Then head off the objection someone in the room is already forming. Yes, averaging those thousand draws recovers the true value, which is exactly what the peak landing on the red line shows. That is the auditor's view rather than a usage pattern: a query is privatized once, on submit. The moment one person emits the same query a thousand times, an attacker can average it back, which is why the appendix says privatize on submit and never per keystroke. It is the asymmetry the payoff rests on, pointed the other way. Many draws from one person breaks privacy, one draw each from many people preserves it.</a:t>
+              <a:t>This is the distributional check. It proves the mechanism is implemented correctly. It does not prove an attacker fails, which is why the attacker slide two on exists. Say what the thousand is, because the title does not: one query, one coordinate of its vector, and a thousand independent noise draws on that same true value. You cannot audit a random mechanism from one sample, so you repeat it until the shape shows. Then head off the objection someone in the room is already forming. Yes, averaging those thousand draws recovers the true value, which is exactly what the peak landing on the red line shows. That is the auditor's view rather than a usage pattern: a query is privatized once, on submit. The moment one person emits the same query a thousand times, an attacker can average it back, which is why the appendix says privatize on submit and never per keystroke. It is the asymmetry the payoff rests on, pointed the other way. Many draws from one person breaks privacy, one draw each from many people preserves it.</a:t>
             </a:r>
           </a:p>
         </p:txBody>
@@ -1022,7 +1022,7 @@
           <a:lstStyle/>
           <a:p>
             <a:r>
-              <a:t>The dial, made visible. Same query, same coordinate, same thousand draws. Only epsilon differs. The scale is one over epsilon, so 1.2 gives 0.833 and 10 gives 0.100, about eight times narrower. Say why the shared x axis matters: let each panel scale itself and they look identical, which is the opposite of the point. Then land both halves of the trade. At epsilon 10 the noise is finally smaller than the index itself, 0.141 against a coordinate spread of 0.171, which is why the next part shows utility jumping from 0.72 to 0.98 between epsilon 5 and 10. And that is also the cost: a spread this narrow means someone reading a single sample is reading the true value. There is no setting that is private and accurate for one query, which is what the payoff slides exist to answer.</a:t>
+              <a:t>The dial, made visible. Same query, same coordinate, same thousand draws. Only epsilon differs. The scale is one over epsilon, so 1.2 gives 0.833 and 10 gives 0.100, about eight times narrower. Say why the shared x axis matters: let each panel scale itself and they look identical, which is the opposite of the point. Then land both halves of the trade. At epsilon 10 the noise is finally smaller than the index itself, 0.141 against a coordinate spread of 0.171, which is why the epsilon sweep later shows utility jumping from 0.72 to 0.98 between epsilon 5 and 10. And that is also the cost: a spread this narrow means someone reading a single sample is reading the true value. There is no setting that is private and accurate for one query, which is what the payoff slides exist to answer.</a:t>
             </a:r>
           </a:p>
         </p:txBody>
@@ -1162,7 +1162,7 @@
           <a:lstStyle/>
           <a:p>
             <a:r>
-              <a:t>Volunteer the confession here, because no slide makes it for you any more. That demo back in Part 2 was rigged: epsilon 1.2 on a twenty document index, where the attacker learned nothing and neither did the user. Say it yourself. If it comes out in Q&amp;A instead, the talk loses, and volunteering it is what makes the payoff believable. Go to the red line first and stay there. That is the demo from Part 2, with the top hit correct 7 percent of the time against a 5 percent baseline, and the top five 45 against 25. Barely above guessing. Then sweep right to make the second point, that utility only returns as epsilon rises, and by then the attacker is reading the query too. Note the curves rise here where slide 16's rose for the attacker: up means the search still works. Exact values if asked: at epsilon 1.2, P@1 0.07 and R@5 0.45; at 3, 0.38 and 0.75; at 5, 0.72 and 0.95; at 10, 0.98 and 1.00. Resist calling epsilon 3 to 5 a usable window. P@1 of 0.38 is eight times chance, so the attacker is already doing well there. The honest version of that argument needs the real index, which is the next slide.</a:t>
+              <a:t>Volunteer the confession here, because no slide makes it for you any more. That demo back in Part 2 was rigged: epsilon 1.2 on a twenty document index, where the attacker learned nothing and neither did the user. Say it yourself. If it comes out in Q&amp;A instead, the talk loses, and volunteering it is what makes the payoff believable. Go to the red line first and stay there. That is the demo from Part 2, with the top hit correct 7 percent of the time against a 5 percent baseline, and the top five 45 against 25. Barely above guessing. Then sweep right to make the second point, that utility only returns as epsilon rises, and by then the attacker is reading the query too. Note the curves rise here where slide 17's rose for the attacker, so up means the search still works. Exact values if asked: at epsilon 1.2, P@1 0.07 and R@5 0.45; at 3, 0.38 and 0.75; at 5, 0.72 and 0.95; at 10, 0.98 and 1.00. Resist calling epsilon 3 to 5 a usable window. P@1 of 0.38 is eight times chance, so the attacker is already doing well there. The honest version of that argument needed the real index, which is the attacker curve you showed a slide ago.</a:t>
             </a:r>
           </a:p>
         </p:txBody>
@@ -1302,7 +1302,7 @@
           <a:lstStyle/>
           <a:p>
             <a:r>
-              <a:t>Keep this to about 30 seconds. The credential that matters for this talk is the PII redaction work, because it is why the privacy problem is familiar rather than academic. The UBI maintainership is why the OpenSearch half is credible. Do not read the list.</a:t>
+              <a:t>Keep this to about 30 seconds. The redaction work is no longer a bullet but is still worth saying out loud, because it is why the privacy problem is familiar rather than academic. The UBI maintainership is why the OpenSearch half is credible. Do not read the list.</a:t>
             </a:r>
           </a:p>
         </p:txBody>
@@ -1862,7 +1862,7 @@
           <a:lstStyle/>
           <a:p>
             <a:r>
-              <a:t>Tie back to the abstract's promise about LTR and query-intent analysis. Then name the thing that genuinely goes away. If anyone presses on the learning-to-rank bullet, be straight: LTR judgments come from clicks, and this mechanism does not touch clicks, so that signal survives because it was never protected rather than because LDP preserved it. The limitations slide says so.</a:t>
+              <a:t>Tie back to the abstract's promise about LTR and query-intent analysis. Then name the thing that genuinely goes away. If anyone presses on the learning-to-rank bullet, be straight: LTR judgments come from clicks, and this mechanism does not touch clicks, so that signal survives because it was never protected rather than because LDP preserved it. The next slide shows how that training actually works, and the limitations slide after it says what does not.</a:t>
             </a:r>
           </a:p>
         </p:txBody>

</xml_diff>

<commit_message>
Drop the time budgets
The talk structure carried a 45 minute slot and a per-part budget, and
the four section divider notes opened with a figure each. None of it was
load bearing, and the numbers had stopped matching the deck anyway after
the restructure, so the plan and the notes were disagreeing about the
shape of the talk.

The cut plan survives as "If you have to cut", since what to drop and
what cannot go is useful independent of any clock. The Part 3 note still
warns that it is the longest part, just without a number on it.

Co-Authored-By: Claude Opus 5 (1M context) <noreply@anthropic.com>
</commit_message>
<xml_diff>
--- a/ldp_for_search_slides.pptx
+++ b/ldp_for_search_slides.pptx
@@ -742,7 +742,7 @@
           <a:lstStyle/>
           <a:p>
             <a:r>
-              <a:t>The longest part by far, about 25 minutes, because it carries the mechanism, the evidence, the cost and the payoff. Three evidence slides in order of strength, the distribution audit, then the epsilon comparison, then the attacker. Then what the noise costs, then what survives it. No divider marks the payoff any more, so the turn from the epsilon sweep to the asymmetry slide is yours to make out loud.</a:t>
+              <a:t>The longest part by far, because it carries the mechanism, the evidence, the cost and the payoff. Three evidence slides in order of strength, the distribution audit, then the epsilon comparison, then the attacker. Then what the noise costs, then what survives it. No divider marks the payoff any more, so the turn from the epsilon sweep to the asymmetry slide is yours to make out loud.</a:t>
             </a:r>
           </a:p>
         </p:txBody>
@@ -1652,7 +1652,7 @@
           <a:lstStyle/>
           <a:p>
             <a:r>
-              <a:t>About 7 minutes. Land the integration, then be honest about what does not work.</a:t>
+              <a:t>Land the integration, then be honest about what does not work.</a:t>
             </a:r>
           </a:p>
         </p:txBody>
@@ -2072,7 +2072,7 @@
           <a:lstStyle/>
           <a:p>
             <a:r>
-              <a:t>About 8 minutes. Goal is that everyone understands the problem before any code appears.</a:t>
+              <a:t>Everyone has to understand the problem before any code appears.</a:t>
             </a:r>
           </a:p>
         </p:txBody>
@@ -2562,7 +2562,7 @@
           <a:lstStyle/>
           <a:p>
             <a:r>
-              <a:t>About 5 minutes. This exists to kill the objection half the room is already forming.</a:t>
+              <a:t>This exists to kill the objection half the room is already forming.</a:t>
             </a:r>
           </a:p>
         </p:txBody>

</xml_diff>

<commit_message>
Define a segment, and trim the about and injection slides
Segment appeared on five slides and was defined on none, after the two
slides that used to introduce it were cut. The epsilon slide now says
what one is, immediately before it starts making claims about them, and
its note carries the production version, that the grouping key has to be
something the server can see without reading the query.

The threshold bullet came off that slide, so no user count now appears
on screen anywhere and the note says it is yours to give if asked.

Also retitles the central versus local comparison, drops the company
name and rewords the last bullet on the about slide, and shortens the
epsilon line on the injection slide.

Co-Authored-By: Claude Opus 5 (1M context) <noreply@anthropic.com>
</commit_message>
<xml_diff>
--- a/ldp_for_search_slides.pptx
+++ b/ldp_for_search_slides.pptx
@@ -1371,7 +1371,7 @@
           <a:lstStyle/>
           <a:p>
             <a:r>
-              <a:t>This now carries the one operational number they can apply on Monday, so slow down on the third bullet. The 2,300 is where the measured error crosses the spread of the index, 0.128, on the convergence plot in the notebook. That bar is strict on purpose, since two typical products sit about 0.82 apart, and it is specific to this index. It is not a constant, because error goes as one over epsilon times one over root n, so the threshold scales as one over epsilon squared, which puts it at about 9,200 users at epsilon 0.5 and about 575 at epsilon 2. The question everyone is holding, answered now that they have seen the evidence for every step. Step one is the reframe: there is no epsilon that is private and accurate for one query, so stop looking for it on the tradeoff curve. Point back to the attack curve for step two, because that is how you measure what an epsilon buys on an index you actually run. Step three is the third bullet here. Step four is the whole talk in one line: error goes as one over epsilon times one over root n, so privacy rides on epsilon alone while accuracy has two dials, and n is the one that costs nothing. If someone wants a starting number, say epsilon 1 on an index like this one and then measure, rather than giving them a figure to carry home unexamined.</a:t>
+              <a:t>The first bullet is the only definition of a segment anywhere in the deck, so say it rather than reading past it. In the notebook a segment is a topical cohort, everyone searching for beds, but in production it is a storefront, a locale, an A/B arm or a device type. The one constraint is that the grouping key has to be something the server can see without reading the query, so it travels as metadata on the noised submission. The threshold itself is no longer on a slide, so it is yours to give if they want a number. The 2,300 is where the measured error crosses the spread of the index, 0.128, on the convergence plot in the notebook. That bar is strict on purpose, since two typical products sit about 0.82 apart, and it is specific to this index. It is not a constant, because error goes as one over epsilon times one over root n, so the threshold scales as one over epsilon squared, which puts it at about 9,200 users at epsilon 0.5 and about 575 at epsilon 2. The question everyone is holding, answered now that they have seen the evidence for every step. Step one is the reframe: there is no epsilon that is private and accurate for one query, so stop looking for it on the tradeoff curve. Point back to the attack curve for step two, because that is how you measure what an epsilon buys on an index you actually run. Step three is the third bullet here. Step four is the whole talk in one line: error goes as one over epsilon times one over root n, so privacy rides on epsilon alone while accuracy has two dials, and n is the one that costs nothing. If someone wants a starting number, say epsilon 1 on an index like this one and then measure, rather than giving them a figure to carry home unexamined.</a:t>
             </a:r>
           </a:p>
         </p:txBody>
@@ -6567,7 +6567,7 @@
                 </a:solidFill>
                 <a:latin typeface="Helvetica Neue"/>
               </a:rPr>
-              <a:t>Two places to add the noise</a:t>
+              <a:t>(Local) Differential Privacy</a:t>
             </a:r>
           </a:p>
         </p:txBody>
@@ -8510,7 +8510,7 @@
                 </a:solidFill>
                 <a:latin typeface="Helvetica Neue"/>
               </a:rPr>
-              <a:t>Independent consultant at Mountain Fog</a:t>
+              <a:t>Independent consultant</a:t>
             </a:r>
           </a:p>
           <a:p>
@@ -8585,7 +8585,7 @@
                 </a:solidFill>
                 <a:latin typeface="Helvetica Neue"/>
               </a:rPr>
-              <a:t>Works in search, NLP, and privacy</a:t>
+              <a:t>Works primarily in cloud, search, and NLP</a:t>
             </a:r>
           </a:p>
           <a:p>
@@ -8839,7 +8839,7 @@
                 </a:solidFill>
                 <a:latin typeface="Helvetica Neue"/>
               </a:rPr>
-              <a:t>A segment needs roughly 2,300 users at epsilon 1, and halving epsilon needs four times that</a:t>
+              <a:t>A segment is any group you would slice a dashboard by</a:t>
             </a:r>
           </a:p>
           <a:p>
@@ -9396,7 +9396,7 @@
                 </a:solidFill>
                 <a:latin typeface="Helvetica Neue"/>
               </a:rPr>
-              <a:t>You set epsilon in the client you ship</a:t>
+              <a:t>You set epsilon in the client</a:t>
             </a:r>
           </a:p>
         </p:txBody>

</xml_diff>

<commit_message>
Drop the ubi_events scope bullet from the limitations
Leaves three limitations on screen. The scope it stated, that this
protects user_query while ubi_events still holds clicks and ids in the
clear, is now spoken rather than shown, and three slides quietly depend
on the room knowing it, namely the closing statement, the dashboards
slide and the learning-to-rank slide whose labels survive precisely
because clicks were never protected.

Co-Authored-By: Claude Opus 5 (1M context) <noreply@anthropic.com>
</commit_message>
<xml_diff>
--- a/ldp_for_search_slides.pptx
+++ b/ldp_for_search_slides.pptx
@@ -10861,67 +10861,6 @@
                 <a:latin typeface="Helvetica Neue"/>
               </a:rPr>
               <a:t>Long tail queries stay unmeasurable</a:t>
-            </a:r>
-          </a:p>
-          <a:p>
-            <a:pPr marL="342900" indent="-342900">
-              <a:spcAft>
-                <a:spcPts val="2000"/>
-              </a:spcAft>
-            </a:pPr>
-            <a:r>
-              <a:rPr sz="2400" b="1">
-                <a:solidFill>
-                  <a:srgbClr val="B4311A"/>
-                </a:solidFill>
-                <a:latin typeface="Helvetica Neue"/>
-              </a:rPr>
-              <a:t>-   </a:t>
-            </a:r>
-            <a:r>
-              <a:rPr sz="2400" b="0" i="0">
-                <a:solidFill>
-                  <a:srgbClr val="141B2D"/>
-                </a:solidFill>
-                <a:latin typeface="Helvetica Neue"/>
-              </a:rPr>
-              <a:t>This protects </a:t>
-            </a:r>
-            <a:r>
-              <a:rPr sz="2200" b="0">
-                <a:solidFill>
-                  <a:srgbClr val="141B2D"/>
-                </a:solidFill>
-                <a:latin typeface="Consolas"/>
-              </a:rPr>
-              <a:t>user_query</a:t>
-            </a:r>
-            <a:r>
-              <a:rPr sz="2400" b="0" i="0">
-                <a:solidFill>
-                  <a:srgbClr val="141B2D"/>
-                </a:solidFill>
-                <a:latin typeface="Helvetica Neue"/>
-              </a:rPr>
-              <a:t> but </a:t>
-            </a:r>
-            <a:r>
-              <a:rPr sz="2200" b="0">
-                <a:solidFill>
-                  <a:srgbClr val="141B2D"/>
-                </a:solidFill>
-                <a:latin typeface="Consolas"/>
-              </a:rPr>
-              <a:t>ubi_events</a:t>
-            </a:r>
-            <a:r>
-              <a:rPr sz="2400" b="0" i="0">
-                <a:solidFill>
-                  <a:srgbClr val="141B2D"/>
-                </a:solidFill>
-                <a:latin typeface="Helvetica Neue"/>
-              </a:rPr>
-              <a:t> still holds clicks and ids in the clear</a:t>
             </a:r>
           </a:p>
         </p:txBody>

</xml_diff>